<commit_message>
Redesign presentation with temple illustration and visual layouts
</commit_message>
<xml_diff>
--- a/Vorlage_Petrol_Gold.pptx
+++ b/Vorlage_Petrol_Gold.pptx
@@ -506,7 +506,7 @@
           <a:lstStyle/>
           <a:p>
             <a:r>
-              <a:t>Vorlagenfolie duplizieren und Platzhaltertexte ersetzen. Farben: Petrol #143D43, Gold #C89C51, Creme #F5EFE3. Keine Bilder sind eingebettet; verwendete Bilder prüfen und Quellen ergänzen.</a:t>
+              <a:t>Vorlagenfolie duplizieren und Platzhalter ersetzen. Titelbild ist eine KI-Illustration eines hinduistischen Tempels, kein dokumentarisches Foto. Bei anderen Themen das Bild ersetzen. Bildnachweise ergänzen. Farben: Petrol #143D43, Gold #C89C51, Creme #F5EFE3.</a:t>
             </a:r>
           </a:p>
         </p:txBody>
@@ -576,7 +576,7 @@
           <a:lstStyle/>
           <a:p>
             <a:r>
-              <a:t>Vorlagenfolie duplizieren und Platzhaltertexte ersetzen. Farben: Petrol #143D43, Gold #C89C51, Creme #F5EFE3. Keine Bilder sind eingebettet; verwendete Bilder prüfen und Quellen ergänzen.</a:t>
+              <a:t>Vorlagenfolie duplizieren und Platzhalter ersetzen. Titelbild ist eine KI-Illustration eines hinduistischen Tempels, kein dokumentarisches Foto. Bei anderen Themen das Bild ersetzen. Bildnachweise ergänzen. Farben: Petrol #143D43, Gold #C89C51, Creme #F5EFE3.</a:t>
             </a:r>
           </a:p>
         </p:txBody>
@@ -646,7 +646,7 @@
           <a:lstStyle/>
           <a:p>
             <a:r>
-              <a:t>Vorlagenfolie duplizieren und Platzhaltertexte ersetzen. Farben: Petrol #143D43, Gold #C89C51, Creme #F5EFE3. Keine Bilder sind eingebettet; verwendete Bilder prüfen und Quellen ergänzen.</a:t>
+              <a:t>Vorlagenfolie duplizieren und Platzhalter ersetzen. Titelbild ist eine KI-Illustration eines hinduistischen Tempels, kein dokumentarisches Foto. Bei anderen Themen das Bild ersetzen. Bildnachweise ergänzen. Farben: Petrol #143D43, Gold #C89C51, Creme #F5EFE3.</a:t>
             </a:r>
           </a:p>
         </p:txBody>
@@ -716,7 +716,7 @@
           <a:lstStyle/>
           <a:p>
             <a:r>
-              <a:t>Vorlagenfolie duplizieren und Platzhaltertexte ersetzen. Farben: Petrol #143D43, Gold #C89C51, Creme #F5EFE3. Keine Bilder sind eingebettet; verwendete Bilder prüfen und Quellen ergänzen.</a:t>
+              <a:t>Vorlagenfolie duplizieren und Platzhalter ersetzen. Titelbild ist eine KI-Illustration eines hinduistischen Tempels, kein dokumentarisches Foto. Bei anderen Themen das Bild ersetzen. Bildnachweise ergänzen. Farben: Petrol #143D43, Gold #C89C51, Creme #F5EFE3.</a:t>
             </a:r>
           </a:p>
         </p:txBody>
@@ -786,7 +786,7 @@
           <a:lstStyle/>
           <a:p>
             <a:r>
-              <a:t>Vorlagenfolie duplizieren und Platzhaltertexte ersetzen. Farben: Petrol #143D43, Gold #C89C51, Creme #F5EFE3. Keine Bilder sind eingebettet; verwendete Bilder prüfen und Quellen ergänzen.</a:t>
+              <a:t>Vorlagenfolie duplizieren und Platzhalter ersetzen. Titelbild ist eine KI-Illustration eines hinduistischen Tempels, kein dokumentarisches Foto. Bei anderen Themen das Bild ersetzen. Bildnachweise ergänzen. Farben: Petrol #143D43, Gold #C89C51, Creme #F5EFE3.</a:t>
             </a:r>
           </a:p>
         </p:txBody>
@@ -3802,14 +3802,92 @@
       <p:grpSpPr/>
       <p:sp>
         <p:nvSpPr>
-          <p:cNvPr id="2" name="Rectangle 1"/>
+          <p:cNvPr id="2" name="TextBox 1"/>
+          <p:cNvSpPr txBox="1"/>
+          <p:nvPr/>
+        </p:nvSpPr>
+        <p:spPr>
+          <a:xfrm>
+            <a:off x="594360" y="365760"/>
+            <a:ext cx="10058400" cy="274320"/>
+          </a:xfrm>
+          <a:prstGeom prst="rect">
+            <a:avLst/>
+          </a:prstGeom>
+          <a:noFill/>
+        </p:spPr>
+        <p:txBody>
+          <a:bodyPr wrap="square" lIns="0" rIns="0" tIns="0" bIns="0">
+            <a:spAutoFit/>
+          </a:bodyPr>
+          <a:lstStyle/>
+          <a:p>
+            <a:pPr>
+              <a:spcAft>
+                <a:spcPts val="1000"/>
+              </a:spcAft>
+              <a:defRPr sz="1100" b="1">
+                <a:solidFill>
+                  <a:srgbClr val="C89C51"/>
+                </a:solidFill>
+                <a:latin typeface="Aptos"/>
+              </a:defRPr>
+            </a:pPr>
+            <a:r>
+              <a:t>[THEMA · NAME · DATUM]</a:t>
+            </a:r>
+          </a:p>
+        </p:txBody>
+      </p:sp>
+      <p:sp>
+        <p:nvSpPr>
+          <p:cNvPr id="3" name="TextBox 2"/>
+          <p:cNvSpPr txBox="1"/>
+          <p:nvPr/>
+        </p:nvSpPr>
+        <p:spPr>
+          <a:xfrm>
+            <a:off x="594360" y="868680"/>
+            <a:ext cx="10972800" cy="1005840"/>
+          </a:xfrm>
+          <a:prstGeom prst="rect">
+            <a:avLst/>
+          </a:prstGeom>
+          <a:noFill/>
+        </p:spPr>
+        <p:txBody>
+          <a:bodyPr wrap="square" lIns="0" rIns="0" tIns="0" bIns="0">
+            <a:spAutoFit/>
+          </a:bodyPr>
+          <a:lstStyle/>
+          <a:p>
+            <a:pPr>
+              <a:spcAft>
+                <a:spcPts val="1000"/>
+              </a:spcAft>
+              <a:defRPr sz="3400" b="1">
+                <a:solidFill>
+                  <a:srgbClr val="F5EFE3"/>
+                </a:solidFill>
+                <a:latin typeface="Aptos"/>
+              </a:defRPr>
+            </a:pPr>
+            <a:r>
+              <a:t>[Titel der Präsentation]</a:t>
+            </a:r>
+          </a:p>
+        </p:txBody>
+      </p:sp>
+      <p:sp>
+        <p:nvSpPr>
+          <p:cNvPr id="4" name="Rectangle 3"/>
           <p:cNvSpPr/>
           <p:nvPr/>
         </p:nvSpPr>
         <p:spPr>
           <a:xfrm>
-            <a:off x="548640" y="594360"/>
-            <a:ext cx="109728" cy="5440680"/>
+            <a:off x="594360" y="6382512"/>
+            <a:ext cx="10972800" cy="18288"/>
           </a:xfrm>
           <a:prstGeom prst="rect">
             <a:avLst/>
@@ -3845,14 +3923,14 @@
       </p:sp>
       <p:sp>
         <p:nvSpPr>
-          <p:cNvPr id="3" name="TextBox 2"/>
+          <p:cNvPr id="5" name="TextBox 4"/>
           <p:cNvSpPr txBox="1"/>
           <p:nvPr/>
         </p:nvSpPr>
         <p:spPr>
           <a:xfrm>
-            <a:off x="868680" y="457200"/>
-            <a:ext cx="10607040" cy="365760"/>
+            <a:off x="594360" y="6510528"/>
+            <a:ext cx="8229600" cy="182880"/>
           </a:xfrm>
           <a:prstGeom prst="rect">
             <a:avLst/>
@@ -3860,16 +3938,16 @@
           <a:noFill/>
         </p:spPr>
         <p:txBody>
-          <a:bodyPr wrap="square">
+          <a:bodyPr wrap="square" lIns="0" rIns="0" tIns="0" bIns="0">
             <a:spAutoFit/>
           </a:bodyPr>
           <a:lstStyle/>
           <a:p>
             <a:pPr>
               <a:spcAft>
-                <a:spcPts val="1800"/>
+                <a:spcPts val="1000"/>
               </a:spcAft>
-              <a:defRPr sz="1200" b="1">
+              <a:defRPr sz="900" b="0">
                 <a:solidFill>
                   <a:srgbClr val="C89C51"/>
                 </a:solidFill>
@@ -3877,21 +3955,21 @@
               </a:defRPr>
             </a:pPr>
             <a:r>
-              <a:t>PRÄSENTATIONSVORLAGE</a:t>
-            </a:r>
-          </a:p>
-        </p:txBody>
-      </p:sp>
-      <p:sp>
-        <p:nvSpPr>
-          <p:cNvPr id="4" name="TextBox 3"/>
+              <a:t>RELIGION · KLASSE 13     /     VIELFALT VERSTEHEN</a:t>
+            </a:r>
+          </a:p>
+        </p:txBody>
+      </p:sp>
+      <p:sp>
+        <p:nvSpPr>
+          <p:cNvPr id="6" name="TextBox 5"/>
           <p:cNvSpPr txBox="1"/>
           <p:nvPr/>
         </p:nvSpPr>
         <p:spPr>
           <a:xfrm>
-            <a:off x="868680" y="1005840"/>
-            <a:ext cx="10515600" cy="1143000"/>
+            <a:off x="10972800" y="6492240"/>
+            <a:ext cx="594360" cy="228600"/>
           </a:xfrm>
           <a:prstGeom prst="rect">
             <a:avLst/>
@@ -3899,108 +3977,14 @@
           <a:noFill/>
         </p:spPr>
         <p:txBody>
-          <a:bodyPr wrap="square">
+          <a:bodyPr wrap="square" lIns="0" rIns="0" tIns="0" bIns="0">
             <a:spAutoFit/>
           </a:bodyPr>
           <a:lstStyle/>
           <a:p>
             <a:pPr>
               <a:spcAft>
-                <a:spcPts val="1800"/>
-              </a:spcAft>
-              <a:defRPr sz="3400" b="1">
-                <a:solidFill>
-                  <a:srgbClr val="F5EFE3"/>
-                </a:solidFill>
-                <a:latin typeface="Aptos"/>
-              </a:defRPr>
-            </a:pPr>
-            <a:r>
-              <a:t>[Titel der Präsentation]</a:t>
-            </a:r>
-          </a:p>
-        </p:txBody>
-      </p:sp>
-      <p:sp>
-        <p:nvSpPr>
-          <p:cNvPr id="5" name="TextBox 4"/>
-          <p:cNvSpPr txBox="1"/>
-          <p:nvPr/>
-        </p:nvSpPr>
-        <p:spPr>
-          <a:xfrm>
-            <a:off x="914400" y="2377440"/>
-            <a:ext cx="10241280" cy="3566160"/>
-          </a:xfrm>
-          <a:prstGeom prst="rect">
-            <a:avLst/>
-          </a:prstGeom>
-          <a:noFill/>
-        </p:spPr>
-        <p:txBody>
-          <a:bodyPr wrap="square">
-            <a:spAutoFit/>
-          </a:bodyPr>
-          <a:lstStyle/>
-          <a:p>
-            <a:pPr>
-              <a:spcAft>
-                <a:spcPts val="1800"/>
-              </a:spcAft>
-              <a:defRPr sz="2500" b="0">
-                <a:solidFill>
-                  <a:srgbClr val="F5EFE3"/>
-                </a:solidFill>
-                <a:latin typeface="Aptos"/>
-              </a:defRPr>
-            </a:pPr>
-            <a:r>
-              <a:t>[Leitfrage]</a:t>
-            </a:r>
-          </a:p>
-          <a:p>
-            <a:pPr>
-              <a:spcAft>
-                <a:spcPts val="1800"/>
-              </a:spcAft>
-              <a:defRPr sz="2500" b="0">
-                <a:solidFill>
-                  <a:srgbClr val="F5EFE3"/>
-                </a:solidFill>
-                <a:latin typeface="Aptos"/>
-              </a:defRPr>
-            </a:pPr>
-            <a:r>
-              <a:t>[Name · Kurs · Datum]</a:t>
-            </a:r>
-          </a:p>
-        </p:txBody>
-      </p:sp>
-      <p:sp>
-        <p:nvSpPr>
-          <p:cNvPr id="6" name="TextBox 5"/>
-          <p:cNvSpPr txBox="1"/>
-          <p:nvPr/>
-        </p:nvSpPr>
-        <p:spPr>
-          <a:xfrm>
-            <a:off x="914400" y="6446520"/>
-            <a:ext cx="9144000" cy="228600"/>
-          </a:xfrm>
-          <a:prstGeom prst="rect">
-            <a:avLst/>
-          </a:prstGeom>
-          <a:noFill/>
-        </p:spPr>
-        <p:txBody>
-          <a:bodyPr wrap="square">
-            <a:spAutoFit/>
-          </a:bodyPr>
-          <a:lstStyle/>
-          <a:p>
-            <a:pPr>
-              <a:spcAft>
-                <a:spcPts val="1800"/>
+                <a:spcPts val="1000"/>
               </a:spcAft>
               <a:defRPr sz="1000" b="0">
                 <a:solidFill>
@@ -4010,21 +3994,45 @@
               </a:defRPr>
             </a:pPr>
             <a:r>
-              <a:t>Vielfalt verstehen · Begriffe verbinden · kritisch nachfragen</a:t>
-            </a:r>
-          </a:p>
-        </p:txBody>
-      </p:sp>
-      <p:sp>
-        <p:nvSpPr>
-          <p:cNvPr id="7" name="TextBox 6"/>
+              <a:t>01</a:t>
+            </a:r>
+          </a:p>
+        </p:txBody>
+      </p:sp>
+      <p:pic>
+        <p:nvPicPr>
+          <p:cNvPr id="7" name="Picture 6" descr="hindu_illustration.png"/>
+          <p:cNvPicPr>
+            <a:picLocks noChangeAspect="1"/>
+          </p:cNvPicPr>
+          <p:nvPr/>
+        </p:nvPicPr>
+        <p:blipFill>
+          <a:blip r:embed="rId3"/>
+          <a:stretch>
+            <a:fillRect/>
+          </a:stretch>
+        </p:blipFill>
+        <p:spPr>
+          <a:xfrm>
+            <a:off x="6217920" y="1828800"/>
+            <a:ext cx="5212080" cy="2933354"/>
+          </a:xfrm>
+          <a:prstGeom prst="rect">
+            <a:avLst/>
+          </a:prstGeom>
+        </p:spPr>
+      </p:pic>
+      <p:sp>
+        <p:nvSpPr>
+          <p:cNvPr id="8" name="TextBox 7"/>
           <p:cNvSpPr txBox="1"/>
           <p:nvPr/>
         </p:nvSpPr>
         <p:spPr>
           <a:xfrm>
-            <a:off x="10972800" y="6428232"/>
-            <a:ext cx="457200" cy="274320"/>
+            <a:off x="731520" y="2468880"/>
+            <a:ext cx="5212080" cy="2560320"/>
           </a:xfrm>
           <a:prstGeom prst="rect">
             <a:avLst/>
@@ -4032,24 +4040,40 @@
           <a:noFill/>
         </p:spPr>
         <p:txBody>
-          <a:bodyPr wrap="square">
+          <a:bodyPr wrap="square" lIns="0" rIns="0" tIns="0" bIns="0">
             <a:spAutoFit/>
           </a:bodyPr>
           <a:lstStyle/>
           <a:p>
             <a:pPr>
               <a:spcAft>
-                <a:spcPts val="1800"/>
+                <a:spcPts val="1000"/>
               </a:spcAft>
-              <a:defRPr sz="1100" b="0">
+              <a:defRPr sz="3000" b="0">
                 <a:solidFill>
-                  <a:srgbClr val="C89C51"/>
+                  <a:srgbClr val="F5EFE3"/>
                 </a:solidFill>
                 <a:latin typeface="Aptos"/>
               </a:defRPr>
             </a:pPr>
             <a:r>
-              <a:t>1</a:t>
+              <a:t>[Leitfrage]</a:t>
+            </a:r>
+          </a:p>
+          <a:p>
+            <a:pPr>
+              <a:spcAft>
+                <a:spcPts val="1000"/>
+              </a:spcAft>
+              <a:defRPr sz="3000" b="0">
+                <a:solidFill>
+                  <a:srgbClr val="F5EFE3"/>
+                </a:solidFill>
+                <a:latin typeface="Aptos"/>
+              </a:defRPr>
+            </a:pPr>
+            <a:r>
+              <a:t>[Untertitel]</a:t>
             </a:r>
           </a:p>
         </p:txBody>
@@ -4082,14 +4106,92 @@
       <p:grpSpPr/>
       <p:sp>
         <p:nvSpPr>
-          <p:cNvPr id="2" name="Rectangle 1"/>
+          <p:cNvPr id="2" name="TextBox 1"/>
+          <p:cNvSpPr txBox="1"/>
+          <p:nvPr/>
+        </p:nvSpPr>
+        <p:spPr>
+          <a:xfrm>
+            <a:off x="594360" y="365760"/>
+            <a:ext cx="10058400" cy="274320"/>
+          </a:xfrm>
+          <a:prstGeom prst="rect">
+            <a:avLst/>
+          </a:prstGeom>
+          <a:noFill/>
+        </p:spPr>
+        <p:txBody>
+          <a:bodyPr wrap="square" lIns="0" rIns="0" tIns="0" bIns="0">
+            <a:spAutoFit/>
+          </a:bodyPr>
+          <a:lstStyle/>
+          <a:p>
+            <a:pPr>
+              <a:spcAft>
+                <a:spcPts val="1000"/>
+              </a:spcAft>
+              <a:defRPr sz="1100" b="1">
+                <a:solidFill>
+                  <a:srgbClr val="C89C51"/>
+                </a:solidFill>
+                <a:latin typeface="Aptos"/>
+              </a:defRPr>
+            </a:pPr>
+            <a:r>
+              <a:t>[KAPITEL]</a:t>
+            </a:r>
+          </a:p>
+        </p:txBody>
+      </p:sp>
+      <p:sp>
+        <p:nvSpPr>
+          <p:cNvPr id="3" name="TextBox 2"/>
+          <p:cNvSpPr txBox="1"/>
+          <p:nvPr/>
+        </p:nvSpPr>
+        <p:spPr>
+          <a:xfrm>
+            <a:off x="594360" y="868680"/>
+            <a:ext cx="10972800" cy="1005840"/>
+          </a:xfrm>
+          <a:prstGeom prst="rect">
+            <a:avLst/>
+          </a:prstGeom>
+          <a:noFill/>
+        </p:spPr>
+        <p:txBody>
+          <a:bodyPr wrap="square" lIns="0" rIns="0" tIns="0" bIns="0">
+            <a:spAutoFit/>
+          </a:bodyPr>
+          <a:lstStyle/>
+          <a:p>
+            <a:pPr>
+              <a:spcAft>
+                <a:spcPts val="1000"/>
+              </a:spcAft>
+              <a:defRPr sz="3400" b="1">
+                <a:solidFill>
+                  <a:srgbClr val="143D43"/>
+                </a:solidFill>
+                <a:latin typeface="Aptos"/>
+              </a:defRPr>
+            </a:pPr>
+            <a:r>
+              <a:t>[Drei Kerngedanken]</a:t>
+            </a:r>
+          </a:p>
+        </p:txBody>
+      </p:sp>
+      <p:sp>
+        <p:nvSpPr>
+          <p:cNvPr id="4" name="Rectangle 3"/>
           <p:cNvSpPr/>
           <p:nvPr/>
         </p:nvSpPr>
         <p:spPr>
           <a:xfrm>
-            <a:off x="548640" y="594360"/>
-            <a:ext cx="109728" cy="5440680"/>
+            <a:off x="594360" y="6382512"/>
+            <a:ext cx="10972800" cy="18288"/>
           </a:xfrm>
           <a:prstGeom prst="rect">
             <a:avLst/>
@@ -4125,14 +4227,14 @@
       </p:sp>
       <p:sp>
         <p:nvSpPr>
-          <p:cNvPr id="3" name="TextBox 2"/>
+          <p:cNvPr id="5" name="TextBox 4"/>
           <p:cNvSpPr txBox="1"/>
           <p:nvPr/>
         </p:nvSpPr>
         <p:spPr>
           <a:xfrm>
-            <a:off x="868680" y="457200"/>
-            <a:ext cx="10607040" cy="365760"/>
+            <a:off x="594360" y="6510528"/>
+            <a:ext cx="8229600" cy="182880"/>
           </a:xfrm>
           <a:prstGeom prst="rect">
             <a:avLst/>
@@ -4140,16 +4242,16 @@
           <a:noFill/>
         </p:spPr>
         <p:txBody>
-          <a:bodyPr wrap="square">
+          <a:bodyPr wrap="square" lIns="0" rIns="0" tIns="0" bIns="0">
             <a:spAutoFit/>
           </a:bodyPr>
           <a:lstStyle/>
           <a:p>
             <a:pPr>
               <a:spcAft>
-                <a:spcPts val="1800"/>
+                <a:spcPts val="1000"/>
               </a:spcAft>
-              <a:defRPr sz="1200" b="1">
+              <a:defRPr sz="900" b="0">
                 <a:solidFill>
                   <a:srgbClr val="C89C51"/>
                 </a:solidFill>
@@ -4157,21 +4259,21 @@
               </a:defRPr>
             </a:pPr>
             <a:r>
-              <a:t>PRÄSENTATIONSVORLAGE</a:t>
-            </a:r>
-          </a:p>
-        </p:txBody>
-      </p:sp>
-      <p:sp>
-        <p:nvSpPr>
-          <p:cNvPr id="4" name="TextBox 3"/>
+              <a:t>RELIGION · KLASSE 13     /     VIELFALT VERSTEHEN</a:t>
+            </a:r>
+          </a:p>
+        </p:txBody>
+      </p:sp>
+      <p:sp>
+        <p:nvSpPr>
+          <p:cNvPr id="6" name="TextBox 5"/>
           <p:cNvSpPr txBox="1"/>
           <p:nvPr/>
         </p:nvSpPr>
         <p:spPr>
           <a:xfrm>
-            <a:off x="868680" y="1005840"/>
-            <a:ext cx="10515600" cy="1143000"/>
+            <a:off x="10972800" y="6492240"/>
+            <a:ext cx="594360" cy="228600"/>
           </a:xfrm>
           <a:prstGeom prst="rect">
             <a:avLst/>
@@ -4179,124 +4281,14 @@
           <a:noFill/>
         </p:spPr>
         <p:txBody>
-          <a:bodyPr wrap="square">
+          <a:bodyPr wrap="square" lIns="0" rIns="0" tIns="0" bIns="0">
             <a:spAutoFit/>
           </a:bodyPr>
           <a:lstStyle/>
           <a:p>
             <a:pPr>
               <a:spcAft>
-                <a:spcPts val="1800"/>
-              </a:spcAft>
-              <a:defRPr sz="3400" b="1">
-                <a:solidFill>
-                  <a:srgbClr val="143D43"/>
-                </a:solidFill>
-                <a:latin typeface="Aptos"/>
-              </a:defRPr>
-            </a:pPr>
-            <a:r>
-              <a:t>[Thema / Kapitel]</a:t>
-            </a:r>
-          </a:p>
-        </p:txBody>
-      </p:sp>
-      <p:sp>
-        <p:nvSpPr>
-          <p:cNvPr id="5" name="TextBox 4"/>
-          <p:cNvSpPr txBox="1"/>
-          <p:nvPr/>
-        </p:nvSpPr>
-        <p:spPr>
-          <a:xfrm>
-            <a:off x="914400" y="2377440"/>
-            <a:ext cx="10241280" cy="3566160"/>
-          </a:xfrm>
-          <a:prstGeom prst="rect">
-            <a:avLst/>
-          </a:prstGeom>
-          <a:noFill/>
-        </p:spPr>
-        <p:txBody>
-          <a:bodyPr wrap="square">
-            <a:spAutoFit/>
-          </a:bodyPr>
-          <a:lstStyle/>
-          <a:p>
-            <a:pPr>
-              <a:spcAft>
-                <a:spcPts val="1800"/>
-              </a:spcAft>
-              <a:defRPr sz="2500" b="0">
-                <a:solidFill>
-                  <a:srgbClr val="173238"/>
-                </a:solidFill>
-                <a:latin typeface="Aptos"/>
-              </a:defRPr>
-            </a:pPr>
-            <a:r>
-              <a:t>[Kernaussage]</a:t>
-            </a:r>
-          </a:p>
-          <a:p>
-            <a:pPr>
-              <a:spcAft>
-                <a:spcPts val="1800"/>
-              </a:spcAft>
-              <a:defRPr sz="2500" b="0">
-                <a:solidFill>
-                  <a:srgbClr val="173238"/>
-                </a:solidFill>
-                <a:latin typeface="Aptos"/>
-              </a:defRPr>
-            </a:pPr>
-            <a:r>
-              <a:t>[Begriff oder Beispiel]</a:t>
-            </a:r>
-          </a:p>
-          <a:p>
-            <a:pPr>
-              <a:spcAft>
-                <a:spcPts val="1800"/>
-              </a:spcAft>
-              <a:defRPr sz="2500" b="0">
-                <a:solidFill>
-                  <a:srgbClr val="173238"/>
-                </a:solidFill>
-                <a:latin typeface="Aptos"/>
-              </a:defRPr>
-            </a:pPr>
-            <a:r>
-              <a:t>[Einordnung]</a:t>
-            </a:r>
-          </a:p>
-        </p:txBody>
-      </p:sp>
-      <p:sp>
-        <p:nvSpPr>
-          <p:cNvPr id="6" name="TextBox 5"/>
-          <p:cNvSpPr txBox="1"/>
-          <p:nvPr/>
-        </p:nvSpPr>
-        <p:spPr>
-          <a:xfrm>
-            <a:off x="914400" y="6446520"/>
-            <a:ext cx="9144000" cy="228600"/>
-          </a:xfrm>
-          <a:prstGeom prst="rect">
-            <a:avLst/>
-          </a:prstGeom>
-          <a:noFill/>
-        </p:spPr>
-        <p:txBody>
-          <a:bodyPr wrap="square">
-            <a:spAutoFit/>
-          </a:bodyPr>
-          <a:lstStyle/>
-          <a:p>
-            <a:pPr>
-              <a:spcAft>
-                <a:spcPts val="1800"/>
+                <a:spcPts val="1000"/>
               </a:spcAft>
               <a:defRPr sz="1000" b="0">
                 <a:solidFill>
@@ -4306,21 +4298,107 @@
               </a:defRPr>
             </a:pPr>
             <a:r>
-              <a:t>Vielfalt verstehen · Begriffe verbinden · kritisch nachfragen</a:t>
-            </a:r>
-          </a:p>
-        </p:txBody>
-      </p:sp>
-      <p:sp>
-        <p:nvSpPr>
-          <p:cNvPr id="7" name="TextBox 6"/>
+              <a:t>02</a:t>
+            </a:r>
+          </a:p>
+        </p:txBody>
+      </p:sp>
+      <p:sp>
+        <p:nvSpPr>
+          <p:cNvPr id="7" name="Rounded Rectangle 6"/>
+          <p:cNvSpPr/>
+          <p:nvPr/>
+        </p:nvSpPr>
+        <p:spPr>
+          <a:xfrm>
+            <a:off x="640080" y="2103120"/>
+            <a:ext cx="3520440" cy="3474720"/>
+          </a:xfrm>
+          <a:prstGeom prst="roundRect">
+            <a:avLst/>
+          </a:prstGeom>
+          <a:solidFill>
+            <a:srgbClr val="FFFFFF"/>
+          </a:solidFill>
+          <a:ln>
+            <a:noFill/>
+          </a:ln>
+        </p:spPr>
+        <p:style>
+          <a:lnRef idx="1">
+            <a:schemeClr val="accent1"/>
+          </a:lnRef>
+          <a:fillRef idx="3">
+            <a:schemeClr val="accent1"/>
+          </a:fillRef>
+          <a:effectRef idx="2">
+            <a:schemeClr val="accent1"/>
+          </a:effectRef>
+          <a:fontRef idx="minor">
+            <a:schemeClr val="lt1"/>
+          </a:fontRef>
+        </p:style>
+        <p:txBody>
+          <a:bodyPr rtlCol="0" anchor="ctr"/>
+          <a:lstStyle/>
+          <a:p>
+            <a:pPr algn="ctr"/>
+          </a:p>
+        </p:txBody>
+      </p:sp>
+      <p:sp>
+        <p:nvSpPr>
+          <p:cNvPr id="8" name="Rectangle 7"/>
+          <p:cNvSpPr/>
+          <p:nvPr/>
+        </p:nvSpPr>
+        <p:spPr>
+          <a:xfrm>
+            <a:off x="822959" y="2304288"/>
+            <a:ext cx="54864" cy="384048"/>
+          </a:xfrm>
+          <a:prstGeom prst="rect">
+            <a:avLst/>
+          </a:prstGeom>
+          <a:solidFill>
+            <a:srgbClr val="C89C51"/>
+          </a:solidFill>
+          <a:ln>
+            <a:noFill/>
+          </a:ln>
+        </p:spPr>
+        <p:style>
+          <a:lnRef idx="1">
+            <a:schemeClr val="accent1"/>
+          </a:lnRef>
+          <a:fillRef idx="3">
+            <a:schemeClr val="accent1"/>
+          </a:fillRef>
+          <a:effectRef idx="2">
+            <a:schemeClr val="accent1"/>
+          </a:effectRef>
+          <a:fontRef idx="minor">
+            <a:schemeClr val="lt1"/>
+          </a:fontRef>
+        </p:style>
+        <p:txBody>
+          <a:bodyPr rtlCol="0" anchor="ctr"/>
+          <a:lstStyle/>
+          <a:p>
+            <a:pPr algn="ctr"/>
+          </a:p>
+        </p:txBody>
+      </p:sp>
+      <p:sp>
+        <p:nvSpPr>
+          <p:cNvPr id="9" name="TextBox 8"/>
           <p:cNvSpPr txBox="1"/>
           <p:nvPr/>
         </p:nvSpPr>
         <p:spPr>
           <a:xfrm>
-            <a:off x="10972800" y="6428232"/>
-            <a:ext cx="457200" cy="274320"/>
+            <a:off x="1005840" y="2286000"/>
+            <a:ext cx="2971800" cy="548640"/>
           </a:xfrm>
           <a:prstGeom prst="rect">
             <a:avLst/>
@@ -4328,24 +4406,439 @@
           <a:noFill/>
         </p:spPr>
         <p:txBody>
-          <a:bodyPr wrap="square">
+          <a:bodyPr wrap="square" lIns="0" rIns="0" tIns="0" bIns="0">
             <a:spAutoFit/>
           </a:bodyPr>
           <a:lstStyle/>
           <a:p>
             <a:pPr>
               <a:spcAft>
-                <a:spcPts val="1800"/>
+                <a:spcPts val="1000"/>
               </a:spcAft>
-              <a:defRPr sz="1100" b="0">
+              <a:defRPr sz="2300" b="1">
                 <a:solidFill>
-                  <a:srgbClr val="C89C51"/>
+                  <a:srgbClr val="143D43"/>
                 </a:solidFill>
                 <a:latin typeface="Aptos"/>
               </a:defRPr>
             </a:pPr>
             <a:r>
-              <a:t>2</a:t>
+              <a:t>[Kernaussage]</a:t>
+            </a:r>
+          </a:p>
+        </p:txBody>
+      </p:sp>
+      <p:sp>
+        <p:nvSpPr>
+          <p:cNvPr id="10" name="TextBox 9"/>
+          <p:cNvSpPr txBox="1"/>
+          <p:nvPr/>
+        </p:nvSpPr>
+        <p:spPr>
+          <a:xfrm>
+            <a:off x="914400" y="2971800"/>
+            <a:ext cx="2971800" cy="2514600"/>
+          </a:xfrm>
+          <a:prstGeom prst="rect">
+            <a:avLst/>
+          </a:prstGeom>
+          <a:noFill/>
+        </p:spPr>
+        <p:txBody>
+          <a:bodyPr wrap="square" lIns="0" rIns="0" tIns="0" bIns="0">
+            <a:spAutoFit/>
+          </a:bodyPr>
+          <a:lstStyle/>
+          <a:p>
+            <a:pPr>
+              <a:spcAft>
+                <a:spcPts val="1000"/>
+              </a:spcAft>
+              <a:defRPr sz="2000" b="0">
+                <a:solidFill>
+                  <a:srgbClr val="173238"/>
+                </a:solidFill>
+                <a:latin typeface="Aptos"/>
+              </a:defRPr>
+            </a:pPr>
+            <a:r>
+              <a:t>[Kurze Erklärung]</a:t>
+            </a:r>
+          </a:p>
+          <a:p>
+            <a:pPr>
+              <a:spcAft>
+                <a:spcPts val="1000"/>
+              </a:spcAft>
+              <a:defRPr sz="2000" b="0">
+                <a:solidFill>
+                  <a:srgbClr val="173238"/>
+                </a:solidFill>
+                <a:latin typeface="Aptos"/>
+              </a:defRPr>
+            </a:pPr>
+            <a:r>
+              <a:t>[Beispiel]</a:t>
+            </a:r>
+          </a:p>
+        </p:txBody>
+      </p:sp>
+      <p:sp>
+        <p:nvSpPr>
+          <p:cNvPr id="11" name="Rounded Rectangle 10"/>
+          <p:cNvSpPr/>
+          <p:nvPr/>
+        </p:nvSpPr>
+        <p:spPr>
+          <a:xfrm>
+            <a:off x="4343400" y="2103120"/>
+            <a:ext cx="3520440" cy="3474720"/>
+          </a:xfrm>
+          <a:prstGeom prst="roundRect">
+            <a:avLst/>
+          </a:prstGeom>
+          <a:solidFill>
+            <a:srgbClr val="FFFFFF"/>
+          </a:solidFill>
+          <a:ln>
+            <a:noFill/>
+          </a:ln>
+        </p:spPr>
+        <p:style>
+          <a:lnRef idx="1">
+            <a:schemeClr val="accent1"/>
+          </a:lnRef>
+          <a:fillRef idx="3">
+            <a:schemeClr val="accent1"/>
+          </a:fillRef>
+          <a:effectRef idx="2">
+            <a:schemeClr val="accent1"/>
+          </a:effectRef>
+          <a:fontRef idx="minor">
+            <a:schemeClr val="lt1"/>
+          </a:fontRef>
+        </p:style>
+        <p:txBody>
+          <a:bodyPr rtlCol="0" anchor="ctr"/>
+          <a:lstStyle/>
+          <a:p>
+            <a:pPr algn="ctr"/>
+          </a:p>
+        </p:txBody>
+      </p:sp>
+      <p:sp>
+        <p:nvSpPr>
+          <p:cNvPr id="12" name="Rectangle 11"/>
+          <p:cNvSpPr/>
+          <p:nvPr/>
+        </p:nvSpPr>
+        <p:spPr>
+          <a:xfrm>
+            <a:off x="4526280" y="2304288"/>
+            <a:ext cx="54864" cy="384048"/>
+          </a:xfrm>
+          <a:prstGeom prst="rect">
+            <a:avLst/>
+          </a:prstGeom>
+          <a:solidFill>
+            <a:srgbClr val="C89C51"/>
+          </a:solidFill>
+          <a:ln>
+            <a:noFill/>
+          </a:ln>
+        </p:spPr>
+        <p:style>
+          <a:lnRef idx="1">
+            <a:schemeClr val="accent1"/>
+          </a:lnRef>
+          <a:fillRef idx="3">
+            <a:schemeClr val="accent1"/>
+          </a:fillRef>
+          <a:effectRef idx="2">
+            <a:schemeClr val="accent1"/>
+          </a:effectRef>
+          <a:fontRef idx="minor">
+            <a:schemeClr val="lt1"/>
+          </a:fontRef>
+        </p:style>
+        <p:txBody>
+          <a:bodyPr rtlCol="0" anchor="ctr"/>
+          <a:lstStyle/>
+          <a:p>
+            <a:pPr algn="ctr"/>
+          </a:p>
+        </p:txBody>
+      </p:sp>
+      <p:sp>
+        <p:nvSpPr>
+          <p:cNvPr id="13" name="TextBox 12"/>
+          <p:cNvSpPr txBox="1"/>
+          <p:nvPr/>
+        </p:nvSpPr>
+        <p:spPr>
+          <a:xfrm>
+            <a:off x="4709160" y="2286000"/>
+            <a:ext cx="2971800" cy="548640"/>
+          </a:xfrm>
+          <a:prstGeom prst="rect">
+            <a:avLst/>
+          </a:prstGeom>
+          <a:noFill/>
+        </p:spPr>
+        <p:txBody>
+          <a:bodyPr wrap="square" lIns="0" rIns="0" tIns="0" bIns="0">
+            <a:spAutoFit/>
+          </a:bodyPr>
+          <a:lstStyle/>
+          <a:p>
+            <a:pPr>
+              <a:spcAft>
+                <a:spcPts val="1000"/>
+              </a:spcAft>
+              <a:defRPr sz="2300" b="1">
+                <a:solidFill>
+                  <a:srgbClr val="143D43"/>
+                </a:solidFill>
+                <a:latin typeface="Aptos"/>
+              </a:defRPr>
+            </a:pPr>
+            <a:r>
+              <a:t>[Kernaussage]</a:t>
+            </a:r>
+          </a:p>
+        </p:txBody>
+      </p:sp>
+      <p:sp>
+        <p:nvSpPr>
+          <p:cNvPr id="14" name="TextBox 13"/>
+          <p:cNvSpPr txBox="1"/>
+          <p:nvPr/>
+        </p:nvSpPr>
+        <p:spPr>
+          <a:xfrm>
+            <a:off x="4617720" y="2971800"/>
+            <a:ext cx="2971800" cy="2514600"/>
+          </a:xfrm>
+          <a:prstGeom prst="rect">
+            <a:avLst/>
+          </a:prstGeom>
+          <a:noFill/>
+        </p:spPr>
+        <p:txBody>
+          <a:bodyPr wrap="square" lIns="0" rIns="0" tIns="0" bIns="0">
+            <a:spAutoFit/>
+          </a:bodyPr>
+          <a:lstStyle/>
+          <a:p>
+            <a:pPr>
+              <a:spcAft>
+                <a:spcPts val="1000"/>
+              </a:spcAft>
+              <a:defRPr sz="2000" b="0">
+                <a:solidFill>
+                  <a:srgbClr val="173238"/>
+                </a:solidFill>
+                <a:latin typeface="Aptos"/>
+              </a:defRPr>
+            </a:pPr>
+            <a:r>
+              <a:t>[Kurze Erklärung]</a:t>
+            </a:r>
+          </a:p>
+          <a:p>
+            <a:pPr>
+              <a:spcAft>
+                <a:spcPts val="1000"/>
+              </a:spcAft>
+              <a:defRPr sz="2000" b="0">
+                <a:solidFill>
+                  <a:srgbClr val="173238"/>
+                </a:solidFill>
+                <a:latin typeface="Aptos"/>
+              </a:defRPr>
+            </a:pPr>
+            <a:r>
+              <a:t>[Beispiel]</a:t>
+            </a:r>
+          </a:p>
+        </p:txBody>
+      </p:sp>
+      <p:sp>
+        <p:nvSpPr>
+          <p:cNvPr id="15" name="Rounded Rectangle 14"/>
+          <p:cNvSpPr/>
+          <p:nvPr/>
+        </p:nvSpPr>
+        <p:spPr>
+          <a:xfrm>
+            <a:off x="8046720" y="2103120"/>
+            <a:ext cx="3520440" cy="3474720"/>
+          </a:xfrm>
+          <a:prstGeom prst="roundRect">
+            <a:avLst/>
+          </a:prstGeom>
+          <a:solidFill>
+            <a:srgbClr val="FFFFFF"/>
+          </a:solidFill>
+          <a:ln>
+            <a:noFill/>
+          </a:ln>
+        </p:spPr>
+        <p:style>
+          <a:lnRef idx="1">
+            <a:schemeClr val="accent1"/>
+          </a:lnRef>
+          <a:fillRef idx="3">
+            <a:schemeClr val="accent1"/>
+          </a:fillRef>
+          <a:effectRef idx="2">
+            <a:schemeClr val="accent1"/>
+          </a:effectRef>
+          <a:fontRef idx="minor">
+            <a:schemeClr val="lt1"/>
+          </a:fontRef>
+        </p:style>
+        <p:txBody>
+          <a:bodyPr rtlCol="0" anchor="ctr"/>
+          <a:lstStyle/>
+          <a:p>
+            <a:pPr algn="ctr"/>
+          </a:p>
+        </p:txBody>
+      </p:sp>
+      <p:sp>
+        <p:nvSpPr>
+          <p:cNvPr id="16" name="Rectangle 15"/>
+          <p:cNvSpPr/>
+          <p:nvPr/>
+        </p:nvSpPr>
+        <p:spPr>
+          <a:xfrm>
+            <a:off x="8229600" y="2304288"/>
+            <a:ext cx="54864" cy="384048"/>
+          </a:xfrm>
+          <a:prstGeom prst="rect">
+            <a:avLst/>
+          </a:prstGeom>
+          <a:solidFill>
+            <a:srgbClr val="C89C51"/>
+          </a:solidFill>
+          <a:ln>
+            <a:noFill/>
+          </a:ln>
+        </p:spPr>
+        <p:style>
+          <a:lnRef idx="1">
+            <a:schemeClr val="accent1"/>
+          </a:lnRef>
+          <a:fillRef idx="3">
+            <a:schemeClr val="accent1"/>
+          </a:fillRef>
+          <a:effectRef idx="2">
+            <a:schemeClr val="accent1"/>
+          </a:effectRef>
+          <a:fontRef idx="minor">
+            <a:schemeClr val="lt1"/>
+          </a:fontRef>
+        </p:style>
+        <p:txBody>
+          <a:bodyPr rtlCol="0" anchor="ctr"/>
+          <a:lstStyle/>
+          <a:p>
+            <a:pPr algn="ctr"/>
+          </a:p>
+        </p:txBody>
+      </p:sp>
+      <p:sp>
+        <p:nvSpPr>
+          <p:cNvPr id="17" name="TextBox 16"/>
+          <p:cNvSpPr txBox="1"/>
+          <p:nvPr/>
+        </p:nvSpPr>
+        <p:spPr>
+          <a:xfrm>
+            <a:off x="8412480" y="2286000"/>
+            <a:ext cx="2971800" cy="548640"/>
+          </a:xfrm>
+          <a:prstGeom prst="rect">
+            <a:avLst/>
+          </a:prstGeom>
+          <a:noFill/>
+        </p:spPr>
+        <p:txBody>
+          <a:bodyPr wrap="square" lIns="0" rIns="0" tIns="0" bIns="0">
+            <a:spAutoFit/>
+          </a:bodyPr>
+          <a:lstStyle/>
+          <a:p>
+            <a:pPr>
+              <a:spcAft>
+                <a:spcPts val="1000"/>
+              </a:spcAft>
+              <a:defRPr sz="2300" b="1">
+                <a:solidFill>
+                  <a:srgbClr val="143D43"/>
+                </a:solidFill>
+                <a:latin typeface="Aptos"/>
+              </a:defRPr>
+            </a:pPr>
+            <a:r>
+              <a:t>[Kernaussage]</a:t>
+            </a:r>
+          </a:p>
+        </p:txBody>
+      </p:sp>
+      <p:sp>
+        <p:nvSpPr>
+          <p:cNvPr id="18" name="TextBox 17"/>
+          <p:cNvSpPr txBox="1"/>
+          <p:nvPr/>
+        </p:nvSpPr>
+        <p:spPr>
+          <a:xfrm>
+            <a:off x="8321040" y="2971800"/>
+            <a:ext cx="2971800" cy="2514600"/>
+          </a:xfrm>
+          <a:prstGeom prst="rect">
+            <a:avLst/>
+          </a:prstGeom>
+          <a:noFill/>
+        </p:spPr>
+        <p:txBody>
+          <a:bodyPr wrap="square" lIns="0" rIns="0" tIns="0" bIns="0">
+            <a:spAutoFit/>
+          </a:bodyPr>
+          <a:lstStyle/>
+          <a:p>
+            <a:pPr>
+              <a:spcAft>
+                <a:spcPts val="1000"/>
+              </a:spcAft>
+              <a:defRPr sz="2000" b="0">
+                <a:solidFill>
+                  <a:srgbClr val="173238"/>
+                </a:solidFill>
+                <a:latin typeface="Aptos"/>
+              </a:defRPr>
+            </a:pPr>
+            <a:r>
+              <a:t>[Kurze Erklärung]</a:t>
+            </a:r>
+          </a:p>
+          <a:p>
+            <a:pPr>
+              <a:spcAft>
+                <a:spcPts val="1000"/>
+              </a:spcAft>
+              <a:defRPr sz="2000" b="0">
+                <a:solidFill>
+                  <a:srgbClr val="173238"/>
+                </a:solidFill>
+                <a:latin typeface="Aptos"/>
+              </a:defRPr>
+            </a:pPr>
+            <a:r>
+              <a:t>[Beispiel]</a:t>
             </a:r>
           </a:p>
         </p:txBody>
@@ -4378,14 +4871,92 @@
       <p:grpSpPr/>
       <p:sp>
         <p:nvSpPr>
-          <p:cNvPr id="2" name="Rectangle 1"/>
+          <p:cNvPr id="2" name="TextBox 1"/>
+          <p:cNvSpPr txBox="1"/>
+          <p:nvPr/>
+        </p:nvSpPr>
+        <p:spPr>
+          <a:xfrm>
+            <a:off x="594360" y="365760"/>
+            <a:ext cx="10058400" cy="274320"/>
+          </a:xfrm>
+          <a:prstGeom prst="rect">
+            <a:avLst/>
+          </a:prstGeom>
+          <a:noFill/>
+        </p:spPr>
+        <p:txBody>
+          <a:bodyPr wrap="square" lIns="0" rIns="0" tIns="0" bIns="0">
+            <a:spAutoFit/>
+          </a:bodyPr>
+          <a:lstStyle/>
+          <a:p>
+            <a:pPr>
+              <a:spcAft>
+                <a:spcPts val="1000"/>
+              </a:spcAft>
+              <a:defRPr sz="1100" b="1">
+                <a:solidFill>
+                  <a:srgbClr val="C89C51"/>
+                </a:solidFill>
+                <a:latin typeface="Aptos"/>
+              </a:defRPr>
+            </a:pPr>
+            <a:r>
+              <a:t>[KAPITEL]</a:t>
+            </a:r>
+          </a:p>
+        </p:txBody>
+      </p:sp>
+      <p:sp>
+        <p:nvSpPr>
+          <p:cNvPr id="3" name="TextBox 2"/>
+          <p:cNvSpPr txBox="1"/>
+          <p:nvPr/>
+        </p:nvSpPr>
+        <p:spPr>
+          <a:xfrm>
+            <a:off x="594360" y="868680"/>
+            <a:ext cx="10972800" cy="1005840"/>
+          </a:xfrm>
+          <a:prstGeom prst="rect">
+            <a:avLst/>
+          </a:prstGeom>
+          <a:noFill/>
+        </p:spPr>
+        <p:txBody>
+          <a:bodyPr wrap="square" lIns="0" rIns="0" tIns="0" bIns="0">
+            <a:spAutoFit/>
+          </a:bodyPr>
+          <a:lstStyle/>
+          <a:p>
+            <a:pPr>
+              <a:spcAft>
+                <a:spcPts val="1000"/>
+              </a:spcAft>
+              <a:defRPr sz="3400" b="1">
+                <a:solidFill>
+                  <a:srgbClr val="143D43"/>
+                </a:solidFill>
+                <a:latin typeface="Aptos"/>
+              </a:defRPr>
+            </a:pPr>
+            <a:r>
+              <a:t>[Vergleich]</a:t>
+            </a:r>
+          </a:p>
+        </p:txBody>
+      </p:sp>
+      <p:sp>
+        <p:nvSpPr>
+          <p:cNvPr id="4" name="Rectangle 3"/>
           <p:cNvSpPr/>
           <p:nvPr/>
         </p:nvSpPr>
         <p:spPr>
           <a:xfrm>
-            <a:off x="548640" y="594360"/>
-            <a:ext cx="109728" cy="5440680"/>
+            <a:off x="594360" y="6382512"/>
+            <a:ext cx="10972800" cy="18288"/>
           </a:xfrm>
           <a:prstGeom prst="rect">
             <a:avLst/>
@@ -4421,14 +4992,14 @@
       </p:sp>
       <p:sp>
         <p:nvSpPr>
-          <p:cNvPr id="3" name="TextBox 2"/>
+          <p:cNvPr id="5" name="TextBox 4"/>
           <p:cNvSpPr txBox="1"/>
           <p:nvPr/>
         </p:nvSpPr>
         <p:spPr>
           <a:xfrm>
-            <a:off x="868680" y="457200"/>
-            <a:ext cx="10607040" cy="365760"/>
+            <a:off x="594360" y="6510528"/>
+            <a:ext cx="8229600" cy="182880"/>
           </a:xfrm>
           <a:prstGeom prst="rect">
             <a:avLst/>
@@ -4436,16 +5007,16 @@
           <a:noFill/>
         </p:spPr>
         <p:txBody>
-          <a:bodyPr wrap="square">
+          <a:bodyPr wrap="square" lIns="0" rIns="0" tIns="0" bIns="0">
             <a:spAutoFit/>
           </a:bodyPr>
           <a:lstStyle/>
           <a:p>
             <a:pPr>
               <a:spcAft>
-                <a:spcPts val="1800"/>
+                <a:spcPts val="1000"/>
               </a:spcAft>
-              <a:defRPr sz="1200" b="1">
+              <a:defRPr sz="900" b="0">
                 <a:solidFill>
                   <a:srgbClr val="C89C51"/>
                 </a:solidFill>
@@ -4453,21 +5024,21 @@
               </a:defRPr>
             </a:pPr>
             <a:r>
-              <a:t>PRÄSENTATIONSVORLAGE</a:t>
-            </a:r>
-          </a:p>
-        </p:txBody>
-      </p:sp>
-      <p:sp>
-        <p:nvSpPr>
-          <p:cNvPr id="4" name="TextBox 3"/>
+              <a:t>RELIGION · KLASSE 13     /     VIELFALT VERSTEHEN</a:t>
+            </a:r>
+          </a:p>
+        </p:txBody>
+      </p:sp>
+      <p:sp>
+        <p:nvSpPr>
+          <p:cNvPr id="6" name="TextBox 5"/>
           <p:cNvSpPr txBox="1"/>
           <p:nvPr/>
         </p:nvSpPr>
         <p:spPr>
           <a:xfrm>
-            <a:off x="868680" y="1005840"/>
-            <a:ext cx="10515600" cy="1143000"/>
+            <a:off x="10972800" y="6492240"/>
+            <a:ext cx="594360" cy="228600"/>
           </a:xfrm>
           <a:prstGeom prst="rect">
             <a:avLst/>
@@ -4475,124 +5046,14 @@
           <a:noFill/>
         </p:spPr>
         <p:txBody>
-          <a:bodyPr wrap="square">
+          <a:bodyPr wrap="square" lIns="0" rIns="0" tIns="0" bIns="0">
             <a:spAutoFit/>
           </a:bodyPr>
           <a:lstStyle/>
           <a:p>
             <a:pPr>
               <a:spcAft>
-                <a:spcPts val="1800"/>
-              </a:spcAft>
-              <a:defRPr sz="3400" b="1">
-                <a:solidFill>
-                  <a:srgbClr val="143D43"/>
-                </a:solidFill>
-                <a:latin typeface="Aptos"/>
-              </a:defRPr>
-            </a:pPr>
-            <a:r>
-              <a:t>[Vergleich]</a:t>
-            </a:r>
-          </a:p>
-        </p:txBody>
-      </p:sp>
-      <p:sp>
-        <p:nvSpPr>
-          <p:cNvPr id="5" name="TextBox 4"/>
-          <p:cNvSpPr txBox="1"/>
-          <p:nvPr/>
-        </p:nvSpPr>
-        <p:spPr>
-          <a:xfrm>
-            <a:off x="914400" y="2377440"/>
-            <a:ext cx="10241280" cy="3566160"/>
-          </a:xfrm>
-          <a:prstGeom prst="rect">
-            <a:avLst/>
-          </a:prstGeom>
-          <a:noFill/>
-        </p:spPr>
-        <p:txBody>
-          <a:bodyPr wrap="square">
-            <a:spAutoFit/>
-          </a:bodyPr>
-          <a:lstStyle/>
-          <a:p>
-            <a:pPr>
-              <a:spcAft>
-                <a:spcPts val="1800"/>
-              </a:spcAft>
-              <a:defRPr sz="2500" b="0">
-                <a:solidFill>
-                  <a:srgbClr val="173238"/>
-                </a:solidFill>
-                <a:latin typeface="Aptos"/>
-              </a:defRPr>
-            </a:pPr>
-            <a:r>
-              <a:t>[Position A: Aussage und Beleg]</a:t>
-            </a:r>
-          </a:p>
-          <a:p>
-            <a:pPr>
-              <a:spcAft>
-                <a:spcPts val="1800"/>
-              </a:spcAft>
-              <a:defRPr sz="2500" b="0">
-                <a:solidFill>
-                  <a:srgbClr val="173238"/>
-                </a:solidFill>
-                <a:latin typeface="Aptos"/>
-              </a:defRPr>
-            </a:pPr>
-            <a:r>
-              <a:t>[Position B: Aussage und Beleg]</a:t>
-            </a:r>
-          </a:p>
-          <a:p>
-            <a:pPr>
-              <a:spcAft>
-                <a:spcPts val="1800"/>
-              </a:spcAft>
-              <a:defRPr sz="2500" b="0">
-                <a:solidFill>
-                  <a:srgbClr val="173238"/>
-                </a:solidFill>
-                <a:latin typeface="Aptos"/>
-              </a:defRPr>
-            </a:pPr>
-            <a:r>
-              <a:t>[Gemeinsamkeit oder Unterschied]</a:t>
-            </a:r>
-          </a:p>
-        </p:txBody>
-      </p:sp>
-      <p:sp>
-        <p:nvSpPr>
-          <p:cNvPr id="6" name="TextBox 5"/>
-          <p:cNvSpPr txBox="1"/>
-          <p:nvPr/>
-        </p:nvSpPr>
-        <p:spPr>
-          <a:xfrm>
-            <a:off x="914400" y="6446520"/>
-            <a:ext cx="9144000" cy="228600"/>
-          </a:xfrm>
-          <a:prstGeom prst="rect">
-            <a:avLst/>
-          </a:prstGeom>
-          <a:noFill/>
-        </p:spPr>
-        <p:txBody>
-          <a:bodyPr wrap="square">
-            <a:spAutoFit/>
-          </a:bodyPr>
-          <a:lstStyle/>
-          <a:p>
-            <a:pPr>
-              <a:spcAft>
-                <a:spcPts val="1800"/>
+                <a:spcPts val="1000"/>
               </a:spcAft>
               <a:defRPr sz="1000" b="0">
                 <a:solidFill>
@@ -4602,21 +5063,107 @@
               </a:defRPr>
             </a:pPr>
             <a:r>
-              <a:t>Vielfalt verstehen · Begriffe verbinden · kritisch nachfragen</a:t>
-            </a:r>
-          </a:p>
-        </p:txBody>
-      </p:sp>
-      <p:sp>
-        <p:nvSpPr>
-          <p:cNvPr id="7" name="TextBox 6"/>
+              <a:t>03</a:t>
+            </a:r>
+          </a:p>
+        </p:txBody>
+      </p:sp>
+      <p:sp>
+        <p:nvSpPr>
+          <p:cNvPr id="7" name="Rounded Rectangle 6"/>
+          <p:cNvSpPr/>
+          <p:nvPr/>
+        </p:nvSpPr>
+        <p:spPr>
+          <a:xfrm>
+            <a:off x="640080" y="2103120"/>
+            <a:ext cx="5303520" cy="3200400"/>
+          </a:xfrm>
+          <a:prstGeom prst="roundRect">
+            <a:avLst/>
+          </a:prstGeom>
+          <a:solidFill>
+            <a:srgbClr val="FFFFFF"/>
+          </a:solidFill>
+          <a:ln>
+            <a:noFill/>
+          </a:ln>
+        </p:spPr>
+        <p:style>
+          <a:lnRef idx="1">
+            <a:schemeClr val="accent1"/>
+          </a:lnRef>
+          <a:fillRef idx="3">
+            <a:schemeClr val="accent1"/>
+          </a:fillRef>
+          <a:effectRef idx="2">
+            <a:schemeClr val="accent1"/>
+          </a:effectRef>
+          <a:fontRef idx="minor">
+            <a:schemeClr val="lt1"/>
+          </a:fontRef>
+        </p:style>
+        <p:txBody>
+          <a:bodyPr rtlCol="0" anchor="ctr"/>
+          <a:lstStyle/>
+          <a:p>
+            <a:pPr algn="ctr"/>
+          </a:p>
+        </p:txBody>
+      </p:sp>
+      <p:sp>
+        <p:nvSpPr>
+          <p:cNvPr id="8" name="Rectangle 7"/>
+          <p:cNvSpPr/>
+          <p:nvPr/>
+        </p:nvSpPr>
+        <p:spPr>
+          <a:xfrm>
+            <a:off x="822959" y="2304288"/>
+            <a:ext cx="54864" cy="384048"/>
+          </a:xfrm>
+          <a:prstGeom prst="rect">
+            <a:avLst/>
+          </a:prstGeom>
+          <a:solidFill>
+            <a:srgbClr val="C89C51"/>
+          </a:solidFill>
+          <a:ln>
+            <a:noFill/>
+          </a:ln>
+        </p:spPr>
+        <p:style>
+          <a:lnRef idx="1">
+            <a:schemeClr val="accent1"/>
+          </a:lnRef>
+          <a:fillRef idx="3">
+            <a:schemeClr val="accent1"/>
+          </a:fillRef>
+          <a:effectRef idx="2">
+            <a:schemeClr val="accent1"/>
+          </a:effectRef>
+          <a:fontRef idx="minor">
+            <a:schemeClr val="lt1"/>
+          </a:fontRef>
+        </p:style>
+        <p:txBody>
+          <a:bodyPr rtlCol="0" anchor="ctr"/>
+          <a:lstStyle/>
+          <a:p>
+            <a:pPr algn="ctr"/>
+          </a:p>
+        </p:txBody>
+      </p:sp>
+      <p:sp>
+        <p:nvSpPr>
+          <p:cNvPr id="9" name="TextBox 8"/>
           <p:cNvSpPr txBox="1"/>
           <p:nvPr/>
         </p:nvSpPr>
         <p:spPr>
           <a:xfrm>
-            <a:off x="10972800" y="6428232"/>
-            <a:ext cx="457200" cy="274320"/>
+            <a:off x="1005840" y="2286000"/>
+            <a:ext cx="4754880" cy="548640"/>
           </a:xfrm>
           <a:prstGeom prst="rect">
             <a:avLst/>
@@ -4624,24 +5171,259 @@
           <a:noFill/>
         </p:spPr>
         <p:txBody>
-          <a:bodyPr wrap="square">
+          <a:bodyPr wrap="square" lIns="0" rIns="0" tIns="0" bIns="0">
             <a:spAutoFit/>
           </a:bodyPr>
           <a:lstStyle/>
           <a:p>
             <a:pPr>
               <a:spcAft>
-                <a:spcPts val="1800"/>
+                <a:spcPts val="1000"/>
               </a:spcAft>
-              <a:defRPr sz="1100" b="0">
+              <a:defRPr sz="2300" b="1">
                 <a:solidFill>
-                  <a:srgbClr val="C89C51"/>
+                  <a:srgbClr val="143D43"/>
                 </a:solidFill>
                 <a:latin typeface="Aptos"/>
               </a:defRPr>
             </a:pPr>
             <a:r>
-              <a:t>3</a:t>
+              <a:t>[Position A]</a:t>
+            </a:r>
+          </a:p>
+        </p:txBody>
+      </p:sp>
+      <p:sp>
+        <p:nvSpPr>
+          <p:cNvPr id="10" name="TextBox 9"/>
+          <p:cNvSpPr txBox="1"/>
+          <p:nvPr/>
+        </p:nvSpPr>
+        <p:spPr>
+          <a:xfrm>
+            <a:off x="914400" y="2971800"/>
+            <a:ext cx="4754880" cy="2240280"/>
+          </a:xfrm>
+          <a:prstGeom prst="rect">
+            <a:avLst/>
+          </a:prstGeom>
+          <a:noFill/>
+        </p:spPr>
+        <p:txBody>
+          <a:bodyPr wrap="square" lIns="0" rIns="0" tIns="0" bIns="0">
+            <a:spAutoFit/>
+          </a:bodyPr>
+          <a:lstStyle/>
+          <a:p>
+            <a:pPr>
+              <a:spcAft>
+                <a:spcPts val="1000"/>
+              </a:spcAft>
+              <a:defRPr sz="2000" b="0">
+                <a:solidFill>
+                  <a:srgbClr val="173238"/>
+                </a:solidFill>
+                <a:latin typeface="Aptos"/>
+              </a:defRPr>
+            </a:pPr>
+            <a:r>
+              <a:t>[Aussage]</a:t>
+            </a:r>
+          </a:p>
+          <a:p>
+            <a:pPr>
+              <a:spcAft>
+                <a:spcPts val="1000"/>
+              </a:spcAft>
+              <a:defRPr sz="2000" b="0">
+                <a:solidFill>
+                  <a:srgbClr val="173238"/>
+                </a:solidFill>
+                <a:latin typeface="Aptos"/>
+              </a:defRPr>
+            </a:pPr>
+            <a:r>
+              <a:t>[Beleg]</a:t>
+            </a:r>
+          </a:p>
+        </p:txBody>
+      </p:sp>
+      <p:sp>
+        <p:nvSpPr>
+          <p:cNvPr id="11" name="Rounded Rectangle 10"/>
+          <p:cNvSpPr/>
+          <p:nvPr/>
+        </p:nvSpPr>
+        <p:spPr>
+          <a:xfrm>
+            <a:off x="6217920" y="2103120"/>
+            <a:ext cx="5303520" cy="3200400"/>
+          </a:xfrm>
+          <a:prstGeom prst="roundRect">
+            <a:avLst/>
+          </a:prstGeom>
+          <a:solidFill>
+            <a:srgbClr val="FFFFFF"/>
+          </a:solidFill>
+          <a:ln>
+            <a:noFill/>
+          </a:ln>
+        </p:spPr>
+        <p:style>
+          <a:lnRef idx="1">
+            <a:schemeClr val="accent1"/>
+          </a:lnRef>
+          <a:fillRef idx="3">
+            <a:schemeClr val="accent1"/>
+          </a:fillRef>
+          <a:effectRef idx="2">
+            <a:schemeClr val="accent1"/>
+          </a:effectRef>
+          <a:fontRef idx="minor">
+            <a:schemeClr val="lt1"/>
+          </a:fontRef>
+        </p:style>
+        <p:txBody>
+          <a:bodyPr rtlCol="0" anchor="ctr"/>
+          <a:lstStyle/>
+          <a:p>
+            <a:pPr algn="ctr"/>
+          </a:p>
+        </p:txBody>
+      </p:sp>
+      <p:sp>
+        <p:nvSpPr>
+          <p:cNvPr id="12" name="Rectangle 11"/>
+          <p:cNvSpPr/>
+          <p:nvPr/>
+        </p:nvSpPr>
+        <p:spPr>
+          <a:xfrm>
+            <a:off x="6400800" y="2304288"/>
+            <a:ext cx="54864" cy="384048"/>
+          </a:xfrm>
+          <a:prstGeom prst="rect">
+            <a:avLst/>
+          </a:prstGeom>
+          <a:solidFill>
+            <a:srgbClr val="C89C51"/>
+          </a:solidFill>
+          <a:ln>
+            <a:noFill/>
+          </a:ln>
+        </p:spPr>
+        <p:style>
+          <a:lnRef idx="1">
+            <a:schemeClr val="accent1"/>
+          </a:lnRef>
+          <a:fillRef idx="3">
+            <a:schemeClr val="accent1"/>
+          </a:fillRef>
+          <a:effectRef idx="2">
+            <a:schemeClr val="accent1"/>
+          </a:effectRef>
+          <a:fontRef idx="minor">
+            <a:schemeClr val="lt1"/>
+          </a:fontRef>
+        </p:style>
+        <p:txBody>
+          <a:bodyPr rtlCol="0" anchor="ctr"/>
+          <a:lstStyle/>
+          <a:p>
+            <a:pPr algn="ctr"/>
+          </a:p>
+        </p:txBody>
+      </p:sp>
+      <p:sp>
+        <p:nvSpPr>
+          <p:cNvPr id="13" name="TextBox 12"/>
+          <p:cNvSpPr txBox="1"/>
+          <p:nvPr/>
+        </p:nvSpPr>
+        <p:spPr>
+          <a:xfrm>
+            <a:off x="6583680" y="2286000"/>
+            <a:ext cx="4754880" cy="548640"/>
+          </a:xfrm>
+          <a:prstGeom prst="rect">
+            <a:avLst/>
+          </a:prstGeom>
+          <a:noFill/>
+        </p:spPr>
+        <p:txBody>
+          <a:bodyPr wrap="square" lIns="0" rIns="0" tIns="0" bIns="0">
+            <a:spAutoFit/>
+          </a:bodyPr>
+          <a:lstStyle/>
+          <a:p>
+            <a:pPr>
+              <a:spcAft>
+                <a:spcPts val="1000"/>
+              </a:spcAft>
+              <a:defRPr sz="2300" b="1">
+                <a:solidFill>
+                  <a:srgbClr val="143D43"/>
+                </a:solidFill>
+                <a:latin typeface="Aptos"/>
+              </a:defRPr>
+            </a:pPr>
+            <a:r>
+              <a:t>[Position B]</a:t>
+            </a:r>
+          </a:p>
+        </p:txBody>
+      </p:sp>
+      <p:sp>
+        <p:nvSpPr>
+          <p:cNvPr id="14" name="TextBox 13"/>
+          <p:cNvSpPr txBox="1"/>
+          <p:nvPr/>
+        </p:nvSpPr>
+        <p:spPr>
+          <a:xfrm>
+            <a:off x="6492240" y="2971800"/>
+            <a:ext cx="4754880" cy="2240280"/>
+          </a:xfrm>
+          <a:prstGeom prst="rect">
+            <a:avLst/>
+          </a:prstGeom>
+          <a:noFill/>
+        </p:spPr>
+        <p:txBody>
+          <a:bodyPr wrap="square" lIns="0" rIns="0" tIns="0" bIns="0">
+            <a:spAutoFit/>
+          </a:bodyPr>
+          <a:lstStyle/>
+          <a:p>
+            <a:pPr>
+              <a:spcAft>
+                <a:spcPts val="1000"/>
+              </a:spcAft>
+              <a:defRPr sz="2000" b="0">
+                <a:solidFill>
+                  <a:srgbClr val="173238"/>
+                </a:solidFill>
+                <a:latin typeface="Aptos"/>
+              </a:defRPr>
+            </a:pPr>
+            <a:r>
+              <a:t>[Aussage]</a:t>
+            </a:r>
+          </a:p>
+          <a:p>
+            <a:pPr>
+              <a:spcAft>
+                <a:spcPts val="1000"/>
+              </a:spcAft>
+              <a:defRPr sz="2000" b="0">
+                <a:solidFill>
+                  <a:srgbClr val="173238"/>
+                </a:solidFill>
+                <a:latin typeface="Aptos"/>
+              </a:defRPr>
+            </a:pPr>
+            <a:r>
+              <a:t>[Beleg]</a:t>
             </a:r>
           </a:p>
         </p:txBody>
@@ -4674,14 +5456,92 @@
       <p:grpSpPr/>
       <p:sp>
         <p:nvSpPr>
-          <p:cNvPr id="2" name="Rectangle 1"/>
+          <p:cNvPr id="2" name="TextBox 1"/>
+          <p:cNvSpPr txBox="1"/>
+          <p:nvPr/>
+        </p:nvSpPr>
+        <p:spPr>
+          <a:xfrm>
+            <a:off x="594360" y="365760"/>
+            <a:ext cx="10058400" cy="274320"/>
+          </a:xfrm>
+          <a:prstGeom prst="rect">
+            <a:avLst/>
+          </a:prstGeom>
+          <a:noFill/>
+        </p:spPr>
+        <p:txBody>
+          <a:bodyPr wrap="square" lIns="0" rIns="0" tIns="0" bIns="0">
+            <a:spAutoFit/>
+          </a:bodyPr>
+          <a:lstStyle/>
+          <a:p>
+            <a:pPr>
+              <a:spcAft>
+                <a:spcPts val="1000"/>
+              </a:spcAft>
+              <a:defRPr sz="1100" b="1">
+                <a:solidFill>
+                  <a:srgbClr val="C89C51"/>
+                </a:solidFill>
+                <a:latin typeface="Aptos"/>
+              </a:defRPr>
+            </a:pPr>
+            <a:r>
+              <a:t>[FAZIT]</a:t>
+            </a:r>
+          </a:p>
+        </p:txBody>
+      </p:sp>
+      <p:sp>
+        <p:nvSpPr>
+          <p:cNvPr id="3" name="TextBox 2"/>
+          <p:cNvSpPr txBox="1"/>
+          <p:nvPr/>
+        </p:nvSpPr>
+        <p:spPr>
+          <a:xfrm>
+            <a:off x="594360" y="868680"/>
+            <a:ext cx="10972800" cy="1005840"/>
+          </a:xfrm>
+          <a:prstGeom prst="rect">
+            <a:avLst/>
+          </a:prstGeom>
+          <a:noFill/>
+        </p:spPr>
+        <p:txBody>
+          <a:bodyPr wrap="square" lIns="0" rIns="0" tIns="0" bIns="0">
+            <a:spAutoFit/>
+          </a:bodyPr>
+          <a:lstStyle/>
+          <a:p>
+            <a:pPr>
+              <a:spcAft>
+                <a:spcPts val="1000"/>
+              </a:spcAft>
+              <a:defRPr sz="3400" b="1">
+                <a:solidFill>
+                  <a:srgbClr val="F5EFE3"/>
+                </a:solidFill>
+                <a:latin typeface="Aptos"/>
+              </a:defRPr>
+            </a:pPr>
+            <a:r>
+              <a:t>[Diskussion]</a:t>
+            </a:r>
+          </a:p>
+        </p:txBody>
+      </p:sp>
+      <p:sp>
+        <p:nvSpPr>
+          <p:cNvPr id="4" name="Rectangle 3"/>
           <p:cNvSpPr/>
           <p:nvPr/>
         </p:nvSpPr>
         <p:spPr>
           <a:xfrm>
-            <a:off x="548640" y="594360"/>
-            <a:ext cx="109728" cy="5440680"/>
+            <a:off x="594360" y="6382512"/>
+            <a:ext cx="10972800" cy="18288"/>
           </a:xfrm>
           <a:prstGeom prst="rect">
             <a:avLst/>
@@ -4717,14 +5577,14 @@
       </p:sp>
       <p:sp>
         <p:nvSpPr>
-          <p:cNvPr id="3" name="TextBox 2"/>
+          <p:cNvPr id="5" name="TextBox 4"/>
           <p:cNvSpPr txBox="1"/>
           <p:nvPr/>
         </p:nvSpPr>
         <p:spPr>
           <a:xfrm>
-            <a:off x="868680" y="457200"/>
-            <a:ext cx="10607040" cy="365760"/>
+            <a:off x="594360" y="6510528"/>
+            <a:ext cx="8229600" cy="182880"/>
           </a:xfrm>
           <a:prstGeom prst="rect">
             <a:avLst/>
@@ -4732,16 +5592,16 @@
           <a:noFill/>
         </p:spPr>
         <p:txBody>
-          <a:bodyPr wrap="square">
+          <a:bodyPr wrap="square" lIns="0" rIns="0" tIns="0" bIns="0">
             <a:spAutoFit/>
           </a:bodyPr>
           <a:lstStyle/>
           <a:p>
             <a:pPr>
               <a:spcAft>
-                <a:spcPts val="1800"/>
+                <a:spcPts val="1000"/>
               </a:spcAft>
-              <a:defRPr sz="1200" b="1">
+              <a:defRPr sz="900" b="0">
                 <a:solidFill>
                   <a:srgbClr val="C89C51"/>
                 </a:solidFill>
@@ -4749,21 +5609,21 @@
               </a:defRPr>
             </a:pPr>
             <a:r>
-              <a:t>PRÄSENTATIONSVORLAGE</a:t>
-            </a:r>
-          </a:p>
-        </p:txBody>
-      </p:sp>
-      <p:sp>
-        <p:nvSpPr>
-          <p:cNvPr id="4" name="TextBox 3"/>
+              <a:t>RELIGION · KLASSE 13     /     VIELFALT VERSTEHEN</a:t>
+            </a:r>
+          </a:p>
+        </p:txBody>
+      </p:sp>
+      <p:sp>
+        <p:nvSpPr>
+          <p:cNvPr id="6" name="TextBox 5"/>
           <p:cNvSpPr txBox="1"/>
           <p:nvPr/>
         </p:nvSpPr>
         <p:spPr>
           <a:xfrm>
-            <a:off x="868680" y="1005840"/>
-            <a:ext cx="10515600" cy="1143000"/>
+            <a:off x="10972800" y="6492240"/>
+            <a:ext cx="594360" cy="228600"/>
           </a:xfrm>
           <a:prstGeom prst="rect">
             <a:avLst/>
@@ -4771,124 +5631,14 @@
           <a:noFill/>
         </p:spPr>
         <p:txBody>
-          <a:bodyPr wrap="square">
+          <a:bodyPr wrap="square" lIns="0" rIns="0" tIns="0" bIns="0">
             <a:spAutoFit/>
           </a:bodyPr>
           <a:lstStyle/>
           <a:p>
             <a:pPr>
               <a:spcAft>
-                <a:spcPts val="1800"/>
-              </a:spcAft>
-              <a:defRPr sz="3400" b="1">
-                <a:solidFill>
-                  <a:srgbClr val="F5EFE3"/>
-                </a:solidFill>
-                <a:latin typeface="Aptos"/>
-              </a:defRPr>
-            </a:pPr>
-            <a:r>
-              <a:t>[Diskussionsfrage]</a:t>
-            </a:r>
-          </a:p>
-        </p:txBody>
-      </p:sp>
-      <p:sp>
-        <p:nvSpPr>
-          <p:cNvPr id="5" name="TextBox 4"/>
-          <p:cNvSpPr txBox="1"/>
-          <p:nvPr/>
-        </p:nvSpPr>
-        <p:spPr>
-          <a:xfrm>
-            <a:off x="914400" y="2377440"/>
-            <a:ext cx="10241280" cy="3566160"/>
-          </a:xfrm>
-          <a:prstGeom prst="rect">
-            <a:avLst/>
-          </a:prstGeom>
-          <a:noFill/>
-        </p:spPr>
-        <p:txBody>
-          <a:bodyPr wrap="square">
-            <a:spAutoFit/>
-          </a:bodyPr>
-          <a:lstStyle/>
-          <a:p>
-            <a:pPr>
-              <a:spcAft>
-                <a:spcPts val="1800"/>
-              </a:spcAft>
-              <a:defRPr sz="2500" b="0">
-                <a:solidFill>
-                  <a:srgbClr val="F5EFE3"/>
-                </a:solidFill>
-                <a:latin typeface="Aptos"/>
-              </a:defRPr>
-            </a:pPr>
-            <a:r>
-              <a:t>[Offene Frage]</a:t>
-            </a:r>
-          </a:p>
-          <a:p>
-            <a:pPr>
-              <a:spcAft>
-                <a:spcPts val="1800"/>
-              </a:spcAft>
-              <a:defRPr sz="2500" b="0">
-                <a:solidFill>
-                  <a:srgbClr val="F5EFE3"/>
-                </a:solidFill>
-                <a:latin typeface="Aptos"/>
-              </a:defRPr>
-            </a:pPr>
-            <a:r>
-              <a:t>[Denkanstoß]</a:t>
-            </a:r>
-          </a:p>
-          <a:p>
-            <a:pPr>
-              <a:spcAft>
-                <a:spcPts val="1800"/>
-              </a:spcAft>
-              <a:defRPr sz="2500" b="0">
-                <a:solidFill>
-                  <a:srgbClr val="F5EFE3"/>
-                </a:solidFill>
-                <a:latin typeface="Aptos"/>
-              </a:defRPr>
-            </a:pPr>
-            <a:r>
-              <a:t>[Ergebnis / Fazit]</a:t>
-            </a:r>
-          </a:p>
-        </p:txBody>
-      </p:sp>
-      <p:sp>
-        <p:nvSpPr>
-          <p:cNvPr id="6" name="TextBox 5"/>
-          <p:cNvSpPr txBox="1"/>
-          <p:nvPr/>
-        </p:nvSpPr>
-        <p:spPr>
-          <a:xfrm>
-            <a:off x="914400" y="6446520"/>
-            <a:ext cx="9144000" cy="228600"/>
-          </a:xfrm>
-          <a:prstGeom prst="rect">
-            <a:avLst/>
-          </a:prstGeom>
-          <a:noFill/>
-        </p:spPr>
-        <p:txBody>
-          <a:bodyPr wrap="square">
-            <a:spAutoFit/>
-          </a:bodyPr>
-          <a:lstStyle/>
-          <a:p>
-            <a:pPr>
-              <a:spcAft>
-                <a:spcPts val="1800"/>
+                <a:spcPts val="1000"/>
               </a:spcAft>
               <a:defRPr sz="1000" b="0">
                 <a:solidFill>
@@ -4898,7 +5648,7 @@
               </a:defRPr>
             </a:pPr>
             <a:r>
-              <a:t>Vielfalt verstehen · Begriffe verbinden · kritisch nachfragen</a:t>
+              <a:t>04</a:t>
             </a:r>
           </a:p>
         </p:txBody>
@@ -4911,8 +5661,8 @@
         </p:nvSpPr>
         <p:spPr>
           <a:xfrm>
-            <a:off x="10972800" y="6428232"/>
-            <a:ext cx="457200" cy="274320"/>
+            <a:off x="731520" y="2377440"/>
+            <a:ext cx="10698480" cy="2286000"/>
           </a:xfrm>
           <a:prstGeom prst="rect">
             <a:avLst/>
@@ -4920,24 +5670,24 @@
           <a:noFill/>
         </p:spPr>
         <p:txBody>
-          <a:bodyPr wrap="square">
+          <a:bodyPr wrap="square" lIns="0" rIns="0" tIns="0" bIns="0">
             <a:spAutoFit/>
           </a:bodyPr>
           <a:lstStyle/>
           <a:p>
             <a:pPr>
               <a:spcAft>
-                <a:spcPts val="1800"/>
+                <a:spcPts val="1000"/>
               </a:spcAft>
-              <a:defRPr sz="1100" b="0">
+              <a:defRPr sz="3600" b="1">
                 <a:solidFill>
-                  <a:srgbClr val="C89C51"/>
+                  <a:srgbClr val="F5EFE3"/>
                 </a:solidFill>
                 <a:latin typeface="Aptos"/>
               </a:defRPr>
             </a:pPr>
             <a:r>
-              <a:t>4</a:t>
+              <a:t>[Offene Frage an die Klasse]</a:t>
             </a:r>
           </a:p>
         </p:txBody>
@@ -4970,14 +5720,92 @@
       <p:grpSpPr/>
       <p:sp>
         <p:nvSpPr>
-          <p:cNvPr id="2" name="Rectangle 1"/>
+          <p:cNvPr id="2" name="TextBox 1"/>
+          <p:cNvSpPr txBox="1"/>
+          <p:nvPr/>
+        </p:nvSpPr>
+        <p:spPr>
+          <a:xfrm>
+            <a:off x="594360" y="365760"/>
+            <a:ext cx="10058400" cy="274320"/>
+          </a:xfrm>
+          <a:prstGeom prst="rect">
+            <a:avLst/>
+          </a:prstGeom>
+          <a:noFill/>
+        </p:spPr>
+        <p:txBody>
+          <a:bodyPr wrap="square" lIns="0" rIns="0" tIns="0" bIns="0">
+            <a:spAutoFit/>
+          </a:bodyPr>
+          <a:lstStyle/>
+          <a:p>
+            <a:pPr>
+              <a:spcAft>
+                <a:spcPts val="1000"/>
+              </a:spcAft>
+              <a:defRPr sz="1100" b="1">
+                <a:solidFill>
+                  <a:srgbClr val="C89C51"/>
+                </a:solidFill>
+                <a:latin typeface="Aptos"/>
+              </a:defRPr>
+            </a:pPr>
+            <a:r>
+              <a:t>[NACHWEISE]</a:t>
+            </a:r>
+          </a:p>
+        </p:txBody>
+      </p:sp>
+      <p:sp>
+        <p:nvSpPr>
+          <p:cNvPr id="3" name="TextBox 2"/>
+          <p:cNvSpPr txBox="1"/>
+          <p:nvPr/>
+        </p:nvSpPr>
+        <p:spPr>
+          <a:xfrm>
+            <a:off x="594360" y="868680"/>
+            <a:ext cx="10972800" cy="1005840"/>
+          </a:xfrm>
+          <a:prstGeom prst="rect">
+            <a:avLst/>
+          </a:prstGeom>
+          <a:noFill/>
+        </p:spPr>
+        <p:txBody>
+          <a:bodyPr wrap="square" lIns="0" rIns="0" tIns="0" bIns="0">
+            <a:spAutoFit/>
+          </a:bodyPr>
+          <a:lstStyle/>
+          <a:p>
+            <a:pPr>
+              <a:spcAft>
+                <a:spcPts val="1000"/>
+              </a:spcAft>
+              <a:defRPr sz="3400" b="1">
+                <a:solidFill>
+                  <a:srgbClr val="143D43"/>
+                </a:solidFill>
+                <a:latin typeface="Aptos"/>
+              </a:defRPr>
+            </a:pPr>
+            <a:r>
+              <a:t>[Quellen]</a:t>
+            </a:r>
+          </a:p>
+        </p:txBody>
+      </p:sp>
+      <p:sp>
+        <p:nvSpPr>
+          <p:cNvPr id="4" name="Rectangle 3"/>
           <p:cNvSpPr/>
           <p:nvPr/>
         </p:nvSpPr>
         <p:spPr>
           <a:xfrm>
-            <a:off x="548640" y="594360"/>
-            <a:ext cx="109728" cy="5440680"/>
+            <a:off x="594360" y="6382512"/>
+            <a:ext cx="10972800" cy="18288"/>
           </a:xfrm>
           <a:prstGeom prst="rect">
             <a:avLst/>
@@ -5013,14 +5841,14 @@
       </p:sp>
       <p:sp>
         <p:nvSpPr>
-          <p:cNvPr id="3" name="TextBox 2"/>
+          <p:cNvPr id="5" name="TextBox 4"/>
           <p:cNvSpPr txBox="1"/>
           <p:nvPr/>
         </p:nvSpPr>
         <p:spPr>
           <a:xfrm>
-            <a:off x="868680" y="457200"/>
-            <a:ext cx="10607040" cy="365760"/>
+            <a:off x="594360" y="6510528"/>
+            <a:ext cx="8229600" cy="182880"/>
           </a:xfrm>
           <a:prstGeom prst="rect">
             <a:avLst/>
@@ -5028,16 +5856,16 @@
           <a:noFill/>
         </p:spPr>
         <p:txBody>
-          <a:bodyPr wrap="square">
+          <a:bodyPr wrap="square" lIns="0" rIns="0" tIns="0" bIns="0">
             <a:spAutoFit/>
           </a:bodyPr>
           <a:lstStyle/>
           <a:p>
             <a:pPr>
               <a:spcAft>
-                <a:spcPts val="1800"/>
+                <a:spcPts val="1000"/>
               </a:spcAft>
-              <a:defRPr sz="1200" b="1">
+              <a:defRPr sz="900" b="0">
                 <a:solidFill>
                   <a:srgbClr val="C89C51"/>
                 </a:solidFill>
@@ -5045,21 +5873,21 @@
               </a:defRPr>
             </a:pPr>
             <a:r>
-              <a:t>PRÄSENTATIONSVORLAGE</a:t>
-            </a:r>
-          </a:p>
-        </p:txBody>
-      </p:sp>
-      <p:sp>
-        <p:nvSpPr>
-          <p:cNvPr id="4" name="TextBox 3"/>
+              <a:t>RELIGION · KLASSE 13     /     VIELFALT VERSTEHEN</a:t>
+            </a:r>
+          </a:p>
+        </p:txBody>
+      </p:sp>
+      <p:sp>
+        <p:nvSpPr>
+          <p:cNvPr id="6" name="TextBox 5"/>
           <p:cNvSpPr txBox="1"/>
           <p:nvPr/>
         </p:nvSpPr>
         <p:spPr>
           <a:xfrm>
-            <a:off x="868680" y="1005840"/>
-            <a:ext cx="10515600" cy="1143000"/>
+            <a:off x="10972800" y="6492240"/>
+            <a:ext cx="594360" cy="228600"/>
           </a:xfrm>
           <a:prstGeom prst="rect">
             <a:avLst/>
@@ -5067,124 +5895,14 @@
           <a:noFill/>
         </p:spPr>
         <p:txBody>
-          <a:bodyPr wrap="square">
+          <a:bodyPr wrap="square" lIns="0" rIns="0" tIns="0" bIns="0">
             <a:spAutoFit/>
           </a:bodyPr>
           <a:lstStyle/>
           <a:p>
             <a:pPr>
               <a:spcAft>
-                <a:spcPts val="1800"/>
-              </a:spcAft>
-              <a:defRPr sz="3400" b="1">
-                <a:solidFill>
-                  <a:srgbClr val="143D43"/>
-                </a:solidFill>
-                <a:latin typeface="Aptos"/>
-              </a:defRPr>
-            </a:pPr>
-            <a:r>
-              <a:t>[Quellen]</a:t>
-            </a:r>
-          </a:p>
-        </p:txBody>
-      </p:sp>
-      <p:sp>
-        <p:nvSpPr>
-          <p:cNvPr id="5" name="TextBox 4"/>
-          <p:cNvSpPr txBox="1"/>
-          <p:nvPr/>
-        </p:nvSpPr>
-        <p:spPr>
-          <a:xfrm>
-            <a:off x="914400" y="2377440"/>
-            <a:ext cx="10241280" cy="3566160"/>
-          </a:xfrm>
-          <a:prstGeom prst="rect">
-            <a:avLst/>
-          </a:prstGeom>
-          <a:noFill/>
-        </p:spPr>
-        <p:txBody>
-          <a:bodyPr wrap="square">
-            <a:spAutoFit/>
-          </a:bodyPr>
-          <a:lstStyle/>
-          <a:p>
-            <a:pPr>
-              <a:spcAft>
-                <a:spcPts val="1800"/>
-              </a:spcAft>
-              <a:defRPr sz="2500" b="0">
-                <a:solidFill>
-                  <a:srgbClr val="173238"/>
-                </a:solidFill>
-                <a:latin typeface="Aptos"/>
-              </a:defRPr>
-            </a:pPr>
-            <a:r>
-              <a:t>[Autor · Titel · Jahr]</a:t>
-            </a:r>
-          </a:p>
-          <a:p>
-            <a:pPr>
-              <a:spcAft>
-                <a:spcPts val="1800"/>
-              </a:spcAft>
-              <a:defRPr sz="2500" b="0">
-                <a:solidFill>
-                  <a:srgbClr val="173238"/>
-                </a:solidFill>
-                <a:latin typeface="Aptos"/>
-              </a:defRPr>
-            </a:pPr>
-            <a:r>
-              <a:t>[URL · Abrufdatum]</a:t>
-            </a:r>
-          </a:p>
-          <a:p>
-            <a:pPr>
-              <a:spcAft>
-                <a:spcPts val="1800"/>
-              </a:spcAft>
-              <a:defRPr sz="2500" b="0">
-                <a:solidFill>
-                  <a:srgbClr val="173238"/>
-                </a:solidFill>
-                <a:latin typeface="Aptos"/>
-              </a:defRPr>
-            </a:pPr>
-            <a:r>
-              <a:t>[Bildnachweise]</a:t>
-            </a:r>
-          </a:p>
-        </p:txBody>
-      </p:sp>
-      <p:sp>
-        <p:nvSpPr>
-          <p:cNvPr id="6" name="TextBox 5"/>
-          <p:cNvSpPr txBox="1"/>
-          <p:nvPr/>
-        </p:nvSpPr>
-        <p:spPr>
-          <a:xfrm>
-            <a:off x="914400" y="6446520"/>
-            <a:ext cx="9144000" cy="228600"/>
-          </a:xfrm>
-          <a:prstGeom prst="rect">
-            <a:avLst/>
-          </a:prstGeom>
-          <a:noFill/>
-        </p:spPr>
-        <p:txBody>
-          <a:bodyPr wrap="square">
-            <a:spAutoFit/>
-          </a:bodyPr>
-          <a:lstStyle/>
-          <a:p>
-            <a:pPr>
-              <a:spcAft>
-                <a:spcPts val="1800"/>
+                <a:spcPts val="1000"/>
               </a:spcAft>
               <a:defRPr sz="1000" b="0">
                 <a:solidFill>
@@ -5194,7 +5912,7 @@
               </a:defRPr>
             </a:pPr>
             <a:r>
-              <a:t>Vielfalt verstehen · Begriffe verbinden · kritisch nachfragen</a:t>
+              <a:t>05</a:t>
             </a:r>
           </a:p>
         </p:txBody>
@@ -5207,8 +5925,8 @@
         </p:nvSpPr>
         <p:spPr>
           <a:xfrm>
-            <a:off x="10972800" y="6428232"/>
-            <a:ext cx="457200" cy="274320"/>
+            <a:off x="731520" y="2103120"/>
+            <a:ext cx="10607040" cy="3474720"/>
           </a:xfrm>
           <a:prstGeom prst="rect">
             <a:avLst/>
@@ -5216,24 +5934,72 @@
           <a:noFill/>
         </p:spPr>
         <p:txBody>
-          <a:bodyPr wrap="square">
+          <a:bodyPr wrap="square" lIns="0" rIns="0" tIns="0" bIns="0">
             <a:spAutoFit/>
           </a:bodyPr>
           <a:lstStyle/>
           <a:p>
             <a:pPr>
               <a:spcAft>
-                <a:spcPts val="1800"/>
+                <a:spcPts val="1000"/>
               </a:spcAft>
-              <a:defRPr sz="1100" b="0">
+              <a:defRPr sz="2200" b="0">
                 <a:solidFill>
-                  <a:srgbClr val="C89C51"/>
+                  <a:srgbClr val="173238"/>
                 </a:solidFill>
                 <a:latin typeface="Aptos"/>
               </a:defRPr>
             </a:pPr>
             <a:r>
-              <a:t>5</a:t>
+              <a:t>[Autor · Titel · Jahr]</a:t>
+            </a:r>
+          </a:p>
+          <a:p>
+            <a:pPr>
+              <a:spcAft>
+                <a:spcPts val="1000"/>
+              </a:spcAft>
+              <a:defRPr sz="2200" b="0">
+                <a:solidFill>
+                  <a:srgbClr val="173238"/>
+                </a:solidFill>
+                <a:latin typeface="Aptos"/>
+              </a:defRPr>
+            </a:pPr>
+            <a:r>
+              <a:t>[URL · Abrufdatum]</a:t>
+            </a:r>
+          </a:p>
+          <a:p>
+            <a:pPr>
+              <a:spcAft>
+                <a:spcPts val="1000"/>
+              </a:spcAft>
+              <a:defRPr sz="2200" b="0">
+                <a:solidFill>
+                  <a:srgbClr val="173238"/>
+                </a:solidFill>
+                <a:latin typeface="Aptos"/>
+              </a:defRPr>
+            </a:pPr>
+            <a:r>
+              <a:t>[Bildquelle / Lizenz]</a:t>
+            </a:r>
+          </a:p>
+          <a:p>
+            <a:pPr>
+              <a:spcAft>
+                <a:spcPts val="1000"/>
+              </a:spcAft>
+              <a:defRPr sz="2200" b="0">
+                <a:solidFill>
+                  <a:srgbClr val="173238"/>
+                </a:solidFill>
+                <a:latin typeface="Aptos"/>
+              </a:defRPr>
+            </a:pPr>
+            <a:r>
+              <a:t>Titelbild: KI-Illustration, mit OpenAI erstellt</a:t>
             </a:r>
           </a:p>
         </p:txBody>

</xml_diff>